<commit_message>
Nuovi titoli delle lezioni 05-09 in lezioni, indice, presentazione e schede
- 05 COLREG e prevenzione degli abbordi; 06 La sicurezza e i suoi elementi
  nella navigazione; 07 Meteorologia e Normativa; 08 Quiz ed esercizi di
  carteggio di navigazione entro le 12 miglia; 09 Vela
- copertine, «Prossima lezione», generatori, README e indice.md
- indice del corso (slide l05-l09 e «Le quindici lezioni»), presentazione
  della scuola e schede riassuntive 05-08
- export rifatti, vecchi file rimossi, link del README aggiornati

Co-Authored-By: Claude Opus 5.5 <noreply@anthropic.com>
Claude-Session: https://claude.ai/code/session_01JPL34mYzgWNhRELUonzupj
</commit_message>
<xml_diff>
--- a/corso/export/pptx/Patente nautica Vela-Motore entro le 12 miglia e senza limiti dalla costa - Fabrizio Fiorucci.pptx
+++ b/corso/export/pptx/Patente nautica Vela-Motore entro le 12 miglia e senza limiti dalla costa - Fabrizio Fiorucci.pptx
@@ -810,7 +810,7 @@
           <a:lstStyle/>
           <a:p>
             <a:r>
-              <a:t>[30 secondi · minuto 6:35] Lezione 5: punto nave e fanali. La fine della scaletta di carteggio della scuola: navigazione costiera, luoghi di posizione, punto nave con due punti cospicui o con uno solo, rilevamento polare, tutti i rilevamenti con le tecniche del punto nave e il GPS: 4 domande su 20 dalla navigazione. Poi la prevenzione degli abbordi, altre 2 domande: fanali, luci speciali, i segnali diurni che abbiamo aggiunto, la gerarchia delle precedenze e il rischio di collisione.</a:t>
+              <a:t>[30 secondi · minuto 6:35] Lezione 5: COLREG e prevenzione degli abbordi. La fine della scaletta di carteggio della scuola: navigazione costiera, luoghi di posizione, punto nave con due punti cospicui o con uno solo, rilevamento polare, tutti i rilevamenti con le tecniche del punto nave e il GPS: 4 domande su 20 dalla navigazione. Poi la prevenzione degli abbordi, altre 2 domande: fanali, luci speciali, i segnali diurni che abbiamo aggiunto, la gerarchia delle precedenze e il rischio di collisione.</a:t>
             </a:r>
           </a:p>
         </p:txBody>
@@ -880,7 +880,7 @@
           <a:lstStyle/>
           <a:p>
             <a:r>
-              <a:t>[30 secondi · minuto 7:05] Lezione 6: segnalamento, segnali sonori e sicurezza. Simboli delle carte, elenco dei fari, caratteristiche e portate, il sistema IALA con laterali, cardinali, pericolo isolato, acque sicure e segnali speciali. Poi i segnali sonori e il comportamento all'ingresso e all'uscita dei porti. Infine la sicurezza, 3 domande su 20: le dotazioni obbligatorie per distanza dalla costa, aggiornate al DM 133 del 2024, l'incendio e, subito dopo, le emergenze: falla, incaglio, collisione, uomo a mare, abbandono, radio VHF, soccorso e cattivo tempo, con il CIRM e le regole su alcol e sostanze. È la lezione più densa: 42 slide.</a:t>
+              <a:t>[30 secondi · minuto 7:05] Lezione 6: la sicurezza e i suoi elementi nella navigazione. I segnali sonori di manovra e in nebbia e le regole nei porti; le dotazioni di sicurezza secondo il DM 133/2024, i mezzi di soccorso e l'incendio; poi le emergenze: falla, incaglio, collisione, uomo a mare, abbandono, la radio VHF e il soccorso, il cattivo tempo, il CIRM, alcol e sostanze. Fari e segnalamento sono passati nella lezione 3.</a:t>
             </a:r>
           </a:p>
         </p:txBody>
@@ -1020,7 +1020,7 @@
           <a:lstStyle/>
           <a:p>
             <a:r>
-              <a:t>[30 secondi · minuto 8:00] Lezione 8, per tutti: è l'ultima lezione della patente entro 12 miglia a motore. Tutta la lezione è dedicata alla prova di carteggio entro 12 miglia: un esercizio dell'elenco ufficiale con 5 quesiti in 20 minuti. Si riprendono gli strumenti e si affronta un quesito alla volta, coordinate, distanza, ora o velocità e carburante, con il metodo e gli errori tipici; poi quattro esercizi ufficiali risolti sulla carta 5/D e una prova simulata a cronometro. Le emergenze sono passate nella lezione 6.</a:t>
+              <a:t>[30 secondi · minuto 8:00] Lezione 8, quiz ed esercizi di carteggio di navigazione entro le 12 miglia, per tutti: è l'ultima lezione della patente entro 12 miglia a motore. Tutta la lezione è dedicata alla prova di carteggio entro 12 miglia: un esercizio dell'elenco ufficiale con 5 quesiti in 20 minuti. Si riprendono gli strumenti e si affronta un quesito alla volta, coordinate, distanza, ora o velocità e carburante, con il metodo e gli errori tipici; poi quattro esercizi ufficiali risolti sulla carta 5/D e una prova simulata a cronometro. Le emergenze sono passate nella lezione 6.</a:t>
             </a:r>
           </a:p>
         </p:txBody>
@@ -2350,7 +2350,7 @@
           <a:lstStyle/>
           <a:p>
             <a:r>
-              <a:t>[30 secondi · minuto 3:30] Ecco le quindici lezioni. Le prime nove, 18 ore, portano alla patente entro 12 miglia: scafo, motori, ormeggi, ancoraggi, carte e segnali, il carteggio con prora e rotta e la condotta sottocosta, punto nave e fanali, segnali sonori, sicurezza ed emergenze, meteo e normativa, poi la lezione 8 tutta dedicata alla prova di carteggio entro 12 miglia, e infine la lezione 9, tutta di vela. Le ultime sei, 12 ore, sono il carteggio oltre le 12 miglia: navigazione costiera, carburante, scarroccio, due lezioni sulle correnti e la carta 42/D. Il carteggio entro 12 miglia si costruisce nelle lezioni 3, 4 e 5 e si prova nella 8 sugli esercizi ufficiali. Le etichette dicono chi segue ogni lezione: la vela è concentrata nella 9, così chi fa solo motore la salta senza perdere nulla. Quattro percorsi: entro 12 miglia motore, lezioni 1-8, 16 ore; entro 12 miglia vela e motore, 1-9, 18 ore; senza limiti motore, tutte tranne la 9, 28 ore; senza limiti vela e motore, tutte e 15, 30 ore.</a:t>
+              <a:t>[30 secondi · minuto 3:30] Ecco le quindici lezioni. Le prime nove, 18 ore, portano alla patente entro 12 miglia: scafo, motori, ormeggi, ancoraggi, carte e segnali, il carteggio con prora e rotta e la condotta sottocosta, COLREG e prevenzione degli abbordi, la sicurezza nella navigazione, meteo e normativa, poi la lezione 8 tutta dedicata alla prova di carteggio entro 12 miglia, e infine la lezione 9, tutta di vela. Le ultime sei, 12 ore, sono il carteggio oltre le 12 miglia: navigazione costiera, carburante, scarroccio, due lezioni sulle correnti e la carta 42/D. Il carteggio entro 12 miglia si costruisce nelle lezioni 3, 4 e 5 e si prova nella 8 sugli esercizi ufficiali. Le etichette dicono chi segue ogni lezione: la vela è concentrata nella 9, così chi fa solo motore la salta senza perdere nulla. Quattro percorsi: entro 12 miglia motore, lezioni 1-8, 16 ore; entro 12 miglia vela e motore, 1-9, 18 ore; senza limiti motore, tutte tranne la 9, 28 ore; senza limiti vela e motore, tutte e 15, 30 ore.</a:t>
             </a:r>
           </a:p>
         </p:txBody>

</xml_diff>

<commit_message>
Lezione 05 rivista sul materiale della scuola; segnali sonori e porti dalla 06
- lezione 05 (77 slide): Che cos'è il COLREG; i fanali uno per uno, motore e
  vela per lunghezza; navi particolari con luci, segnali diurni, viste dai
  quattro lati e trucchetti; scala delle precedenze, regole a motore e a
  vela, rischio di collisione; apparecchi e segnali sonori, nebbia, porti;
  24 casi di luci da riconoscere; verifiche e raccolta quiz rifatte
- lezione 06 (55 slide): tolti segnali sonori, nebbia e porti, quiz sostituiti
- indice del corso, schede 05 e 06, README, indice.md ed export aggiornati

Co-Authored-By: Claude Opus 5.5 <noreply@anthropic.com>
Claude-Session: https://claude.ai/code/session_01JPL34mYzgWNhRELUonzupj
</commit_message>
<xml_diff>
--- a/corso/export/pptx/Patente nautica Vela-Motore entro le 12 miglia e senza limiti dalla costa - Fabrizio Fiorucci.pptx
+++ b/corso/export/pptx/Patente nautica Vela-Motore entro le 12 miglia e senza limiti dalla costa - Fabrizio Fiorucci.pptx
@@ -810,7 +810,7 @@
           <a:lstStyle/>
           <a:p>
             <a:r>
-              <a:t>[30 secondi · minuto 6:35] Lezione 5: COLREG e prevenzione degli abbordi, 2 domande su 20: fanali, luci speciali, i segnali diurni che abbiamo aggiunto, la gerarchia delle precedenze, il rischio di collisione e le regole di rotta. Il carteggio del punto nave e dei rilevamenti è nella lezione 4.</a:t>
+              <a:t>[30 secondi · minuto 6:35] Lezione 5: COLREG e prevenzione degli abbordi, 2 domande su 20. Che cos'è il COLREG; i fanali uno per uno, per il motore e per la vela; le navi particolari con luci e segnali diurni e i trucchetti per ricordarli; la scala delle precedenze, le regole a motore e a vela, il rischio di collisione; i segnali sonori, la nebbia e i porti; per finire 24 casi di luci da riconoscere.</a:t>
             </a:r>
           </a:p>
         </p:txBody>
@@ -880,7 +880,7 @@
           <a:lstStyle/>
           <a:p>
             <a:r>
-              <a:t>[30 secondi · minuto 7:05] Lezione 6: la sicurezza e i suoi elementi nella navigazione. I segnali sonori di manovra e in nebbia e le regole nei porti; le dotazioni di sicurezza secondo il DM 133/2024, i mezzi di soccorso e l'incendio; poi le emergenze: falla, incaglio, collisione, uomo a mare, abbandono, la radio VHF e il soccorso, il cattivo tempo, il CIRM, alcol e sostanze. Fari e segnalamento sono passati nella lezione 3.</a:t>
+              <a:t>[30 secondi · minuto 7:05] Lezione 6: la sicurezza e i suoi elementi nella navigazione. Le dotazioni di sicurezza secondo il DM 133/2024, i mezzi di soccorso e l'incendio; poi le emergenze: falla, incaglio, collisione, uomo a mare, abbandono, la radio VHF e il soccorso, il cattivo tempo, il CIRM, alcol e sostanze. Segnali sonori e porti sono passati nella lezione 5; la lezione sarà rivista sul programma della scuola.</a:t>
             </a:r>
           </a:p>
         </p:txBody>

</xml_diff>